<commit_message>
Update investor deck to include trigger architecture slide
Add a new slide detailing the trigger architecture to the investor deck, enhancing the explanation of the Detect phase.

Replit-Commit-Author: Agent
Replit-Commit-Session-Id: 85f09f3c-352d-446d-b98e-3f307c26fc5a
Replit-Commit-Checkpoint-Type: full_checkpoint
Replit-Commit-Event-Id: f96bd7f6-bd0c-4902-9e9b-384648cdb3f7
Replit-Commit-Screenshot-Url: https://storage.googleapis.com/screenshot-production-us-central1/3bd53afc-ff4f-401b-9e3d-b367791ef629/85f09f3c-352d-446d-b98e-3f307c26fc5a/rWl6hYf
Replit-Helium-Checkpoint-Created: true
</commit_message>
<xml_diff>
--- a/attached_assets/VaughnMartin-Investor-Deck-v14-full.pptx
+++ b/attached_assets/VaughnMartin-Investor-Deck-v14-full.pptx
@@ -10,6 +10,7 @@
     <p:sldId id="258" r:id="rId9"/>
     <p:sldId id="259" r:id="rId10"/>
     <p:sldId id="260" r:id="rId11"/>
+    <p:sldId id="274" r:id="rId25"/>
     <p:sldId id="261" r:id="rId12"/>
     <p:sldId id="262" r:id="rId13"/>
     <p:sldId id="263" r:id="rId14"/>
@@ -3937,7 +3938,7 @@
                 </a:solidFill>
                 <a:latin typeface="Calibri"/>
               </a:rPr>
-              <a:t>00  /  17</a:t>
+              <a:t>00  /  18</a:t>
             </a:r>
           </a:p>
         </p:txBody>
@@ -4191,7 +4192,7 @@
                 </a:solidFill>
                 <a:latin typeface="Calibri"/>
               </a:rPr>
-              <a:t>09  /  17</a:t>
+              <a:t>10  /  18</a:t>
             </a:r>
           </a:p>
         </p:txBody>
@@ -5385,7 +5386,7 @@
                 </a:solidFill>
                 <a:latin typeface="Calibri"/>
               </a:rPr>
-              <a:t>10  /  17</a:t>
+              <a:t>11  /  18</a:t>
             </a:r>
           </a:p>
         </p:txBody>
@@ -6841,7 +6842,7 @@
                 </a:solidFill>
                 <a:latin typeface="Calibri"/>
               </a:rPr>
-              <a:t>11  /  17</a:t>
+              <a:t>12  /  18</a:t>
             </a:r>
           </a:p>
         </p:txBody>
@@ -8592,7 +8593,7 @@
                 </a:solidFill>
                 <a:latin typeface="Calibri"/>
               </a:rPr>
-              <a:t>12  /  17</a:t>
+              <a:t>13  /  18</a:t>
             </a:r>
           </a:p>
         </p:txBody>
@@ -9941,7 +9942,7 @@
                 </a:solidFill>
                 <a:latin typeface="Calibri"/>
               </a:rPr>
-              <a:t>13  /  17</a:t>
+              <a:t>14  /  18</a:t>
             </a:r>
           </a:p>
         </p:txBody>
@@ -11239,7 +11240,7 @@
                 </a:solidFill>
                 <a:latin typeface="Calibri"/>
               </a:rPr>
-              <a:t>14  /  17</a:t>
+              <a:t>15  /  18</a:t>
             </a:r>
           </a:p>
         </p:txBody>
@@ -12675,7 +12676,7 @@
                 </a:solidFill>
                 <a:latin typeface="Calibri"/>
               </a:rPr>
-              <a:t>15  /  17</a:t>
+              <a:t>16  /  18</a:t>
             </a:r>
           </a:p>
         </p:txBody>
@@ -14302,7 +14303,7 @@
                 </a:solidFill>
                 <a:latin typeface="Calibri"/>
               </a:rPr>
-              <a:t>16  /  17</a:t>
+              <a:t>17  /  18</a:t>
             </a:r>
           </a:p>
         </p:txBody>
@@ -14556,7 +14557,7 @@
                 </a:solidFill>
                 <a:latin typeface="Calibri"/>
               </a:rPr>
-              <a:t>17  /  17</a:t>
+              <a:t>18  /  18</a:t>
             </a:r>
           </a:p>
         </p:txBody>
@@ -15396,6 +15397,2150 @@
           <a:lstStyle/>
           <a:p>
             <a:pPr algn="ctr"/>
+          </a:p>
+        </p:txBody>
+      </p:sp>
+    </p:spTree>
+  </p:cSld>
+  <p:clrMapOvr>
+    <a:masterClrMapping/>
+  </p:clrMapOvr>
+</p:sld>
+</file>
+
+<file path=ppt/slides/slide19.xml><?xml version="1.0" encoding="utf-8"?>
+<p:sld xmlns:a="http://schemas.openxmlformats.org/drawingml/2006/main" xmlns:p="http://schemas.openxmlformats.org/presentationml/2006/main" xmlns:r="http://schemas.openxmlformats.org/officeDocument/2006/relationships">
+  <p:cSld>
+    <p:spTree>
+      <p:nvGrpSpPr>
+        <p:cNvPr id="1" name=""/>
+        <p:cNvGrpSpPr/>
+        <p:nvPr/>
+      </p:nvGrpSpPr>
+      <p:grpSpPr/>
+      <p:pic>
+        <p:nvPicPr>
+          <p:cNvPr id="2" name="Picture 1" descr="image.jpg"/>
+          <p:cNvPicPr>
+            <a:picLocks noChangeAspect="1"/>
+          </p:cNvPicPr>
+          <p:nvPr/>
+        </p:nvPicPr>
+        <p:blipFill>
+          <a:blip r:embed="rId2"/>
+          <a:stretch>
+            <a:fillRect/>
+          </a:stretch>
+        </p:blipFill>
+        <p:spPr>
+          <a:xfrm>
+            <a:off x="0" y="0"/>
+            <a:ext cx="12188952" cy="6858000"/>
+          </a:xfrm>
+          <a:prstGeom prst="rect">
+            <a:avLst/>
+          </a:prstGeom>
+        </p:spPr>
+      </p:pic>
+      <p:sp>
+        <p:nvSpPr>
+          <p:cNvPr id="3" name="Rectangle 2"/>
+          <p:cNvSpPr/>
+          <p:nvPr/>
+        </p:nvSpPr>
+        <p:spPr>
+          <a:xfrm>
+            <a:off x="0" y="0"/>
+            <a:ext cx="12188952" cy="22860"/>
+          </a:xfrm>
+          <a:prstGeom prst="rect">
+            <a:avLst/>
+          </a:prstGeom>
+          <a:solidFill>
+            <a:srgbClr val="C9A84C"/>
+          </a:solidFill>
+          <a:ln>
+            <a:noFill/>
+          </a:ln>
+        </p:spPr>
+        <p:style>
+          <a:lnRef idx="1">
+            <a:schemeClr val="accent1"/>
+          </a:lnRef>
+          <a:fillRef idx="3">
+            <a:schemeClr val="accent1"/>
+          </a:fillRef>
+          <a:effectRef idx="2">
+            <a:schemeClr val="accent1"/>
+          </a:effectRef>
+          <a:fontRef idx="minor">
+            <a:schemeClr val="lt1"/>
+          </a:fontRef>
+        </p:style>
+        <p:txBody>
+          <a:bodyPr rtlCol="0" anchor="ctr"/>
+          <a:lstStyle/>
+          <a:p>
+            <a:pPr algn="ctr"/>
+          </a:p>
+        </p:txBody>
+      </p:sp>
+      <p:sp>
+        <p:nvSpPr>
+          <p:cNvPr id="4" name="Rectangle 3"/>
+          <p:cNvSpPr/>
+          <p:nvPr/>
+        </p:nvSpPr>
+        <p:spPr>
+          <a:xfrm>
+            <a:off x="0" y="0"/>
+            <a:ext cx="12188952" cy="6858000"/>
+          </a:xfrm>
+          <a:prstGeom prst="rect">
+            <a:avLst/>
+          </a:prstGeom>
+          <a:solidFill>
+            <a:srgbClr val="0A0F2E"/>
+          </a:solidFill>
+          <a:ln>
+            <a:noFill/>
+          </a:ln>
+        </p:spPr>
+        <p:style>
+          <a:lnRef idx="1">
+            <a:schemeClr val="accent1"/>
+          </a:lnRef>
+          <a:fillRef idx="3">
+            <a:schemeClr val="accent1"/>
+          </a:fillRef>
+          <a:effectRef idx="2">
+            <a:schemeClr val="accent1"/>
+          </a:effectRef>
+          <a:fontRef idx="minor">
+            <a:schemeClr val="lt1"/>
+          </a:fontRef>
+        </p:style>
+        <p:txBody>
+          <a:bodyPr rtlCol="0" anchor="ctr"/>
+          <a:lstStyle/>
+          <a:p>
+            <a:pPr algn="ctr"/>
+          </a:p>
+        </p:txBody>
+      </p:sp>
+      <p:pic>
+        <p:nvPicPr>
+          <p:cNvPr id="5" name="Picture 4" descr="image.png"/>
+          <p:cNvPicPr>
+            <a:picLocks noChangeAspect="1"/>
+          </p:cNvPicPr>
+          <p:nvPr/>
+        </p:nvPicPr>
+        <p:blipFill>
+          <a:blip r:embed="rId3"/>
+          <a:stretch>
+            <a:fillRect/>
+          </a:stretch>
+        </p:blipFill>
+        <p:spPr>
+          <a:xfrm>
+            <a:off x="274320" y="256032"/>
+            <a:ext cx="1645920" cy="411480"/>
+          </a:xfrm>
+          <a:prstGeom prst="rect">
+            <a:avLst/>
+          </a:prstGeom>
+        </p:spPr>
+      </p:pic>
+      <p:sp>
+        <p:nvSpPr>
+          <p:cNvPr id="6" name="Rectangle 5"/>
+          <p:cNvSpPr/>
+          <p:nvPr/>
+        </p:nvSpPr>
+        <p:spPr>
+          <a:xfrm>
+            <a:off x="0" y="6473952"/>
+            <a:ext cx="12188952" cy="18288"/>
+          </a:xfrm>
+          <a:prstGeom prst="rect">
+            <a:avLst/>
+          </a:prstGeom>
+          <a:solidFill>
+            <a:srgbClr val="C9A84C"/>
+          </a:solidFill>
+          <a:ln>
+            <a:noFill/>
+          </a:ln>
+        </p:spPr>
+        <p:style>
+          <a:lnRef idx="1">
+            <a:schemeClr val="accent1"/>
+          </a:lnRef>
+          <a:fillRef idx="3">
+            <a:schemeClr val="accent1"/>
+          </a:fillRef>
+          <a:effectRef idx="2">
+            <a:schemeClr val="accent1"/>
+          </a:effectRef>
+          <a:fontRef idx="minor">
+            <a:schemeClr val="lt1"/>
+          </a:fontRef>
+        </p:style>
+        <p:txBody>
+          <a:bodyPr rtlCol="0" anchor="ctr"/>
+          <a:lstStyle/>
+          <a:p>
+            <a:pPr algn="ctr"/>
+          </a:p>
+        </p:txBody>
+      </p:sp>
+      <p:pic>
+        <p:nvPicPr>
+          <p:cNvPr id="7" name="Picture 6" descr="image.png"/>
+          <p:cNvPicPr>
+            <a:picLocks noChangeAspect="1"/>
+          </p:cNvPicPr>
+          <p:nvPr/>
+        </p:nvPicPr>
+        <p:blipFill>
+          <a:blip r:embed="rId3"/>
+          <a:stretch>
+            <a:fillRect/>
+          </a:stretch>
+        </p:blipFill>
+        <p:spPr>
+          <a:xfrm>
+            <a:off x="274320" y="6547104"/>
+            <a:ext cx="1005840" cy="246888"/>
+          </a:xfrm>
+          <a:prstGeom prst="rect">
+            <a:avLst/>
+          </a:prstGeom>
+        </p:spPr>
+      </p:pic>
+      <p:sp>
+        <p:nvSpPr>
+          <p:cNvPr id="8" name="TextBox 7"/>
+          <p:cNvSpPr txBox="1"/>
+          <p:nvPr/>
+        </p:nvSpPr>
+        <p:spPr>
+          <a:xfrm>
+            <a:off x="11338560" y="6547104"/>
+            <a:ext cx="731520" cy="246888"/>
+          </a:xfrm>
+          <a:prstGeom prst="rect">
+            <a:avLst/>
+          </a:prstGeom>
+          <a:noFill/>
+        </p:spPr>
+        <p:txBody>
+          <a:bodyPr wrap="square">
+            <a:spAutoFit/>
+          </a:bodyPr>
+          <a:lstStyle/>
+          <a:p>
+            <a:pPr algn="r"/>
+            <a:r>
+              <a:rPr sz="700" b="0" i="0">
+                <a:solidFill>
+                  <a:srgbClr val="AAB4CC"/>
+                </a:solidFill>
+                <a:latin typeface="Calibri"/>
+              </a:rPr>
+              <a:t>06  /  18</a:t>
+            </a:r>
+          </a:p>
+        </p:txBody>
+      </p:sp>
+      <p:sp>
+        <p:nvSpPr>
+          <p:cNvPr id="9" name="TextBox 8"/>
+          <p:cNvSpPr txBox="1"/>
+          <p:nvPr/>
+        </p:nvSpPr>
+        <p:spPr>
+          <a:xfrm>
+            <a:off x="438912" y="365760"/>
+            <a:ext cx="10972800" cy="201168"/>
+          </a:xfrm>
+          <a:prstGeom prst="rect">
+            <a:avLst/>
+          </a:prstGeom>
+          <a:noFill/>
+        </p:spPr>
+        <p:txBody>
+          <a:bodyPr wrap="square">
+            <a:spAutoFit/>
+          </a:bodyPr>
+          <a:lstStyle/>
+          <a:p>
+            <a:pPr algn="l"/>
+            <a:r>
+              <a:rPr sz="750" b="1" i="0">
+                <a:solidFill>
+                  <a:srgbClr val="C9A84C"/>
+                </a:solidFill>
+                <a:latin typeface="Calibri"/>
+              </a:rPr>
+              <a:t>── DETECT PHASE — TRIGGER ARCHITECTURE ──</a:t>
+            </a:r>
+          </a:p>
+        </p:txBody>
+      </p:sp>
+      <p:sp>
+        <p:nvSpPr>
+          <p:cNvPr id="10" name="TextBox 9"/>
+          <p:cNvSpPr txBox="1"/>
+          <p:nvPr/>
+        </p:nvSpPr>
+        <p:spPr>
+          <a:xfrm>
+            <a:off x="438912" y="658368"/>
+            <a:ext cx="5669280" cy="731520"/>
+          </a:xfrm>
+          <a:prstGeom prst="rect">
+            <a:avLst/>
+          </a:prstGeom>
+          <a:noFill/>
+        </p:spPr>
+        <p:txBody>
+          <a:bodyPr wrap="square">
+            <a:spAutoFit/>
+          </a:bodyPr>
+          <a:lstStyle/>
+          <a:p>
+            <a:pPr algn="l"/>
+            <a:r>
+              <a:rPr sz="2800" b="1" i="0">
+                <a:solidFill>
+                  <a:srgbClr val="FFFFFF"/>
+                </a:solidFill>
+                <a:latin typeface="Georgia"/>
+              </a:rPr>
+              <a:t>Triggers Are Not Single Signals.</a:t>
+            </a:r>
+          </a:p>
+        </p:txBody>
+      </p:sp>
+      <p:sp>
+        <p:nvSpPr>
+          <p:cNvPr id="11" name="TextBox 10"/>
+          <p:cNvSpPr txBox="1"/>
+          <p:nvPr/>
+        </p:nvSpPr>
+        <p:spPr>
+          <a:xfrm>
+            <a:off x="438912" y="1316736"/>
+            <a:ext cx="5669280" cy="530352"/>
+          </a:xfrm>
+          <a:prstGeom prst="rect">
+            <a:avLst/>
+          </a:prstGeom>
+          <a:noFill/>
+        </p:spPr>
+        <p:txBody>
+          <a:bodyPr wrap="square">
+            <a:spAutoFit/>
+          </a:bodyPr>
+          <a:lstStyle/>
+          <a:p>
+            <a:pPr algn="l"/>
+            <a:r>
+              <a:rPr sz="2000" b="0" i="1">
+                <a:solidFill>
+                  <a:srgbClr val="C9A84C"/>
+                </a:solidFill>
+                <a:latin typeface="Georgia"/>
+              </a:rPr>
+              <a:t>Grouped data points. Individual thresholds. Mandatory conditions.</a:t>
+            </a:r>
+          </a:p>
+        </p:txBody>
+      </p:sp>
+      <p:sp>
+        <p:nvSpPr>
+          <p:cNvPr id="12" name="TextBox 11"/>
+          <p:cNvSpPr txBox="1"/>
+          <p:nvPr/>
+        </p:nvSpPr>
+        <p:spPr>
+          <a:xfrm>
+            <a:off x="438912" y="1627632"/>
+            <a:ext cx="11320272" cy="402336"/>
+          </a:xfrm>
+          <a:prstGeom prst="rect">
+            <a:avLst/>
+          </a:prstGeom>
+          <a:noFill/>
+        </p:spPr>
+        <p:txBody>
+          <a:bodyPr wrap="square">
+            <a:spAutoFit/>
+          </a:bodyPr>
+          <a:lstStyle/>
+          <a:p>
+            <a:pPr algn="l"/>
+            <a:r>
+              <a:rPr sz="1150" b="0" i="0">
+                <a:solidFill>
+                  <a:srgbClr val="AAB4CC"/>
+                </a:solidFill>
+                <a:latin typeface="Calibri"/>
+              </a:rPr>
+              <a:t>Each trigger is an architecture — a defined group of data points that must collectively meet specific conditions before a playbook deploys. No single signal fires a protocol.</a:t>
+            </a:r>
+          </a:p>
+        </p:txBody>
+      </p:sp>
+      <p:sp>
+        <p:nvSpPr>
+          <p:cNvPr id="13" name="TextBox 12"/>
+          <p:cNvSpPr txBox="1"/>
+          <p:nvPr/>
+        </p:nvSpPr>
+        <p:spPr>
+          <a:xfrm>
+            <a:off x="438912" y="2176272"/>
+            <a:ext cx="5303520" cy="219456"/>
+          </a:xfrm>
+          <a:prstGeom prst="rect">
+            <a:avLst/>
+          </a:prstGeom>
+          <a:noFill/>
+        </p:spPr>
+        <p:txBody>
+          <a:bodyPr wrap="square">
+            <a:spAutoFit/>
+          </a:bodyPr>
+          <a:lstStyle/>
+          <a:p>
+            <a:pPr algn="l"/>
+            <a:r>
+              <a:rPr sz="750" b="1" i="0">
+                <a:solidFill>
+                  <a:srgbClr val="C9A84C"/>
+                </a:solidFill>
+                <a:latin typeface="Calibri"/>
+              </a:rPr>
+              <a:t>── THE THREE-THRESHOLD MODEL ──</a:t>
+            </a:r>
+          </a:p>
+        </p:txBody>
+      </p:sp>
+      <p:sp>
+        <p:nvSpPr>
+          <p:cNvPr id="14" name="Rectangle 13"/>
+          <p:cNvSpPr/>
+          <p:nvPr/>
+        </p:nvSpPr>
+        <p:spPr>
+          <a:xfrm>
+            <a:off x="438912" y="2468880"/>
+            <a:ext cx="5303520" cy="1152144"/>
+          </a:xfrm>
+          <a:prstGeom prst="rect">
+            <a:avLst/>
+          </a:prstGeom>
+          <a:solidFill>
+            <a:srgbClr val="070B24"/>
+          </a:solidFill>
+          <a:ln w="9525">
+            <a:solidFill>
+              <a:srgbClr val="C9A84C"/>
+            </a:solidFill>
+          </a:ln>
+        </p:spPr>
+        <p:style>
+          <a:lnRef idx="1">
+            <a:schemeClr val="accent1"/>
+          </a:lnRef>
+          <a:fillRef idx="3">
+            <a:schemeClr val="accent1"/>
+          </a:fillRef>
+          <a:effectRef idx="2">
+            <a:schemeClr val="accent1"/>
+          </a:effectRef>
+          <a:fontRef idx="minor">
+            <a:schemeClr val="lt1"/>
+          </a:fontRef>
+        </p:style>
+        <p:txBody>
+          <a:bodyPr rtlCol="0" anchor="ctr"/>
+          <a:lstStyle/>
+          <a:p>
+            <a:pPr algn="ctr"/>
+          </a:p>
+        </p:txBody>
+      </p:sp>
+      <p:sp>
+        <p:nvSpPr>
+          <p:cNvPr id="15" name="Rectangle 14"/>
+          <p:cNvSpPr/>
+          <p:nvPr/>
+        </p:nvSpPr>
+        <p:spPr>
+          <a:xfrm>
+            <a:off x="438912" y="2468880"/>
+            <a:ext cx="109728" cy="1152144"/>
+          </a:xfrm>
+          <a:prstGeom prst="rect">
+            <a:avLst/>
+          </a:prstGeom>
+          <a:solidFill>
+            <a:srgbClr val="C9A84C"/>
+          </a:solidFill>
+          <a:ln>
+            <a:noFill/>
+          </a:ln>
+        </p:spPr>
+        <p:style>
+          <a:lnRef idx="1">
+            <a:schemeClr val="accent1"/>
+          </a:lnRef>
+          <a:fillRef idx="3">
+            <a:schemeClr val="accent1"/>
+          </a:fillRef>
+          <a:effectRef idx="2">
+            <a:schemeClr val="accent1"/>
+          </a:effectRef>
+          <a:fontRef idx="minor">
+            <a:schemeClr val="lt1"/>
+          </a:fontRef>
+        </p:style>
+        <p:txBody>
+          <a:bodyPr rtlCol="0" anchor="ctr"/>
+          <a:lstStyle/>
+          <a:p>
+            <a:pPr algn="ctr"/>
+          </a:p>
+        </p:txBody>
+      </p:sp>
+      <p:sp>
+        <p:nvSpPr>
+          <p:cNvPr id="16" name="TextBox 15"/>
+          <p:cNvSpPr txBox="1"/>
+          <p:nvPr/>
+        </p:nvSpPr>
+        <p:spPr>
+          <a:xfrm>
+            <a:off x="621792" y="2560320"/>
+            <a:ext cx="4992624" cy="219456"/>
+          </a:xfrm>
+          <a:prstGeom prst="rect">
+            <a:avLst/>
+          </a:prstGeom>
+          <a:noFill/>
+        </p:spPr>
+        <p:txBody>
+          <a:bodyPr wrap="square">
+            <a:spAutoFit/>
+          </a:bodyPr>
+          <a:lstStyle/>
+          <a:p>
+            <a:pPr algn="l"/>
+            <a:r>
+              <a:rPr sz="800" b="1" i="0">
+                <a:solidFill>
+                  <a:srgbClr val="C9A84C"/>
+                </a:solidFill>
+                <a:latin typeface="Calibri"/>
+              </a:rPr>
+              <a:t>LAYER 1 — DATA POINT THRESHOLD</a:t>
+            </a:r>
+          </a:p>
+        </p:txBody>
+      </p:sp>
+      <p:sp>
+        <p:nvSpPr>
+          <p:cNvPr id="17" name="TextBox 16"/>
+          <p:cNvSpPr txBox="1"/>
+          <p:nvPr/>
+        </p:nvSpPr>
+        <p:spPr>
+          <a:xfrm>
+            <a:off x="621792" y="2816352"/>
+            <a:ext cx="4992624" cy="713232"/>
+          </a:xfrm>
+          <a:prstGeom prst="rect">
+            <a:avLst/>
+          </a:prstGeom>
+          <a:noFill/>
+        </p:spPr>
+        <p:txBody>
+          <a:bodyPr wrap="square">
+            <a:spAutoFit/>
+          </a:bodyPr>
+          <a:lstStyle/>
+          <a:p>
+            <a:pPr algn="l"/>
+            <a:r>
+              <a:rPr sz="850" b="0" i="0">
+                <a:solidFill>
+                  <a:srgbClr val="AAB4CC"/>
+                </a:solidFill>
+                <a:latin typeface="Calibri"/>
+              </a:rPr>
+              <a:t>Each individual data point has its own metric it must meet to become a valid signal. A regulatory filing detected. A sentiment score below threshold. A volume anomaly above baseline. Until a data point meets its individual metric, it does not count toward the group.</a:t>
+            </a:r>
+          </a:p>
+        </p:txBody>
+      </p:sp>
+      <p:sp>
+        <p:nvSpPr>
+          <p:cNvPr id="18" name="Rectangle 17"/>
+          <p:cNvSpPr/>
+          <p:nvPr/>
+        </p:nvSpPr>
+        <p:spPr>
+          <a:xfrm>
+            <a:off x="438912" y="3730752"/>
+            <a:ext cx="5303520" cy="1152144"/>
+          </a:xfrm>
+          <a:prstGeom prst="rect">
+            <a:avLst/>
+          </a:prstGeom>
+          <a:solidFill>
+            <a:srgbClr val="070B24"/>
+          </a:solidFill>
+          <a:ln w="9525">
+            <a:solidFill>
+              <a:srgbClr val="2B8A6E"/>
+            </a:solidFill>
+          </a:ln>
+        </p:spPr>
+        <p:style>
+          <a:lnRef idx="1">
+            <a:schemeClr val="accent1"/>
+          </a:lnRef>
+          <a:fillRef idx="3">
+            <a:schemeClr val="accent1"/>
+          </a:fillRef>
+          <a:effectRef idx="2">
+            <a:schemeClr val="accent1"/>
+          </a:effectRef>
+          <a:fontRef idx="minor">
+            <a:schemeClr val="lt1"/>
+          </a:fontRef>
+        </p:style>
+        <p:txBody>
+          <a:bodyPr rtlCol="0" anchor="ctr"/>
+          <a:lstStyle/>
+          <a:p>
+            <a:pPr algn="ctr"/>
+          </a:p>
+        </p:txBody>
+      </p:sp>
+      <p:sp>
+        <p:nvSpPr>
+          <p:cNvPr id="19" name="Rectangle 18"/>
+          <p:cNvSpPr/>
+          <p:nvPr/>
+        </p:nvSpPr>
+        <p:spPr>
+          <a:xfrm>
+            <a:off x="438912" y="3730752"/>
+            <a:ext cx="109728" cy="1152144"/>
+          </a:xfrm>
+          <a:prstGeom prst="rect">
+            <a:avLst/>
+          </a:prstGeom>
+          <a:solidFill>
+            <a:srgbClr val="2B8A6E"/>
+          </a:solidFill>
+          <a:ln>
+            <a:noFill/>
+          </a:ln>
+        </p:spPr>
+        <p:style>
+          <a:lnRef idx="1">
+            <a:schemeClr val="accent1"/>
+          </a:lnRef>
+          <a:fillRef idx="3">
+            <a:schemeClr val="accent1"/>
+          </a:fillRef>
+          <a:effectRef idx="2">
+            <a:schemeClr val="accent1"/>
+          </a:effectRef>
+          <a:fontRef idx="minor">
+            <a:schemeClr val="lt1"/>
+          </a:fontRef>
+        </p:style>
+        <p:txBody>
+          <a:bodyPr rtlCol="0" anchor="ctr"/>
+          <a:lstStyle/>
+          <a:p>
+            <a:pPr algn="ctr"/>
+          </a:p>
+        </p:txBody>
+      </p:sp>
+      <p:sp>
+        <p:nvSpPr>
+          <p:cNvPr id="20" name="TextBox 19"/>
+          <p:cNvSpPr txBox="1"/>
+          <p:nvPr/>
+        </p:nvSpPr>
+        <p:spPr>
+          <a:xfrm>
+            <a:off x="621792" y="3822191"/>
+            <a:ext cx="4992624" cy="219456"/>
+          </a:xfrm>
+          <a:prstGeom prst="rect">
+            <a:avLst/>
+          </a:prstGeom>
+          <a:noFill/>
+        </p:spPr>
+        <p:txBody>
+          <a:bodyPr wrap="square">
+            <a:spAutoFit/>
+          </a:bodyPr>
+          <a:lstStyle/>
+          <a:p>
+            <a:pPr algn="l"/>
+            <a:r>
+              <a:rPr sz="800" b="1" i="0">
+                <a:solidFill>
+                  <a:srgbClr val="2B8A6E"/>
+                </a:solidFill>
+                <a:latin typeface="Calibri"/>
+              </a:rPr>
+              <a:t>LAYER 2 — MANDATORY CONDITIONS</a:t>
+            </a:r>
+          </a:p>
+        </p:txBody>
+      </p:sp>
+      <p:sp>
+        <p:nvSpPr>
+          <p:cNvPr id="21" name="TextBox 20"/>
+          <p:cNvSpPr txBox="1"/>
+          <p:nvPr/>
+        </p:nvSpPr>
+        <p:spPr>
+          <a:xfrm>
+            <a:off x="621792" y="4078224"/>
+            <a:ext cx="4992624" cy="713232"/>
+          </a:xfrm>
+          <a:prstGeom prst="rect">
+            <a:avLst/>
+          </a:prstGeom>
+          <a:noFill/>
+        </p:spPr>
+        <p:txBody>
+          <a:bodyPr wrap="square">
+            <a:spAutoFit/>
+          </a:bodyPr>
+          <a:lstStyle/>
+          <a:p>
+            <a:pPr algn="l"/>
+            <a:r>
+              <a:rPr sz="850" b="0" i="0">
+                <a:solidFill>
+                  <a:srgbClr val="AAB4CC"/>
+                </a:solidFill>
+                <a:latin typeface="Calibri"/>
+              </a:rPr>
+              <a:t>Specific data points within a trigger group can be flagged as mandatory. The trigger group cannot fire — regardless of how many other signals are valid — unless every mandatory data point has been met. This prevents false positives on partial signal sets.</a:t>
+            </a:r>
+          </a:p>
+        </p:txBody>
+      </p:sp>
+      <p:sp>
+        <p:nvSpPr>
+          <p:cNvPr id="22" name="Rectangle 21"/>
+          <p:cNvSpPr/>
+          <p:nvPr/>
+        </p:nvSpPr>
+        <p:spPr>
+          <a:xfrm>
+            <a:off x="438912" y="4992624"/>
+            <a:ext cx="5303520" cy="1152144"/>
+          </a:xfrm>
+          <a:prstGeom prst="rect">
+            <a:avLst/>
+          </a:prstGeom>
+          <a:solidFill>
+            <a:srgbClr val="070B24"/>
+          </a:solidFill>
+          <a:ln w="9525">
+            <a:solidFill>
+              <a:srgbClr val="FFFFFF"/>
+            </a:solidFill>
+          </a:ln>
+        </p:spPr>
+        <p:style>
+          <a:lnRef idx="1">
+            <a:schemeClr val="accent1"/>
+          </a:lnRef>
+          <a:fillRef idx="3">
+            <a:schemeClr val="accent1"/>
+          </a:fillRef>
+          <a:effectRef idx="2">
+            <a:schemeClr val="accent1"/>
+          </a:effectRef>
+          <a:fontRef idx="minor">
+            <a:schemeClr val="lt1"/>
+          </a:fontRef>
+        </p:style>
+        <p:txBody>
+          <a:bodyPr rtlCol="0" anchor="ctr"/>
+          <a:lstStyle/>
+          <a:p>
+            <a:pPr algn="ctr"/>
+          </a:p>
+        </p:txBody>
+      </p:sp>
+      <p:sp>
+        <p:nvSpPr>
+          <p:cNvPr id="23" name="Rectangle 22"/>
+          <p:cNvSpPr/>
+          <p:nvPr/>
+        </p:nvSpPr>
+        <p:spPr>
+          <a:xfrm>
+            <a:off x="438912" y="4992624"/>
+            <a:ext cx="109728" cy="1152144"/>
+          </a:xfrm>
+          <a:prstGeom prst="rect">
+            <a:avLst/>
+          </a:prstGeom>
+          <a:solidFill>
+            <a:srgbClr val="FFFFFF"/>
+          </a:solidFill>
+          <a:ln>
+            <a:noFill/>
+          </a:ln>
+        </p:spPr>
+        <p:style>
+          <a:lnRef idx="1">
+            <a:schemeClr val="accent1"/>
+          </a:lnRef>
+          <a:fillRef idx="3">
+            <a:schemeClr val="accent1"/>
+          </a:fillRef>
+          <a:effectRef idx="2">
+            <a:schemeClr val="accent1"/>
+          </a:effectRef>
+          <a:fontRef idx="minor">
+            <a:schemeClr val="lt1"/>
+          </a:fontRef>
+        </p:style>
+        <p:txBody>
+          <a:bodyPr rtlCol="0" anchor="ctr"/>
+          <a:lstStyle/>
+          <a:p>
+            <a:pPr algn="ctr"/>
+          </a:p>
+        </p:txBody>
+      </p:sp>
+      <p:sp>
+        <p:nvSpPr>
+          <p:cNvPr id="24" name="TextBox 23"/>
+          <p:cNvSpPr txBox="1"/>
+          <p:nvPr/>
+        </p:nvSpPr>
+        <p:spPr>
+          <a:xfrm>
+            <a:off x="621792" y="5084064"/>
+            <a:ext cx="4992624" cy="219456"/>
+          </a:xfrm>
+          <a:prstGeom prst="rect">
+            <a:avLst/>
+          </a:prstGeom>
+          <a:noFill/>
+        </p:spPr>
+        <p:txBody>
+          <a:bodyPr wrap="square">
+            <a:spAutoFit/>
+          </a:bodyPr>
+          <a:lstStyle/>
+          <a:p>
+            <a:pPr algn="l"/>
+            <a:r>
+              <a:rPr sz="800" b="1" i="0">
+                <a:solidFill>
+                  <a:srgbClr val="FFFFFF"/>
+                </a:solidFill>
+                <a:latin typeface="Calibri"/>
+              </a:rPr>
+              <a:t>LAYER 3 — GROUP THRESHOLD</a:t>
+            </a:r>
+          </a:p>
+        </p:txBody>
+      </p:sp>
+      <p:sp>
+        <p:nvSpPr>
+          <p:cNvPr id="25" name="TextBox 24"/>
+          <p:cNvSpPr txBox="1"/>
+          <p:nvPr/>
+        </p:nvSpPr>
+        <p:spPr>
+          <a:xfrm>
+            <a:off x="621792" y="5340096"/>
+            <a:ext cx="4992624" cy="713232"/>
+          </a:xfrm>
+          <a:prstGeom prst="rect">
+            <a:avLst/>
+          </a:prstGeom>
+          <a:noFill/>
+        </p:spPr>
+        <p:txBody>
+          <a:bodyPr wrap="square">
+            <a:spAutoFit/>
+          </a:bodyPr>
+          <a:lstStyle/>
+          <a:p>
+            <a:pPr algn="l"/>
+            <a:r>
+              <a:rPr sz="850" b="0" i="0">
+                <a:solidFill>
+                  <a:srgbClr val="AAB4CC"/>
+                </a:solidFill>
+                <a:latin typeface="Calibri"/>
+              </a:rPr>
+              <a:t>Once individual data points are validated, the group itself must meet a final threshold — a required number or combination of valid signals. Only when the group threshold is crossed does the playbook trigger and move to execution.</a:t>
+            </a:r>
+          </a:p>
+        </p:txBody>
+      </p:sp>
+      <p:sp>
+        <p:nvSpPr>
+          <p:cNvPr id="26" name="Rectangle 25"/>
+          <p:cNvSpPr/>
+          <p:nvPr/>
+        </p:nvSpPr>
+        <p:spPr>
+          <a:xfrm>
+            <a:off x="5980176" y="2103120"/>
+            <a:ext cx="18288" cy="4187952"/>
+          </a:xfrm>
+          <a:prstGeom prst="rect">
+            <a:avLst/>
+          </a:prstGeom>
+          <a:solidFill>
+            <a:srgbClr val="1A2450"/>
+          </a:solidFill>
+          <a:ln>
+            <a:noFill/>
+          </a:ln>
+        </p:spPr>
+        <p:style>
+          <a:lnRef idx="1">
+            <a:schemeClr val="accent1"/>
+          </a:lnRef>
+          <a:fillRef idx="3">
+            <a:schemeClr val="accent1"/>
+          </a:fillRef>
+          <a:effectRef idx="2">
+            <a:schemeClr val="accent1"/>
+          </a:effectRef>
+          <a:fontRef idx="minor">
+            <a:schemeClr val="lt1"/>
+          </a:fontRef>
+        </p:style>
+        <p:txBody>
+          <a:bodyPr rtlCol="0" anchor="ctr"/>
+          <a:lstStyle/>
+          <a:p>
+            <a:pPr algn="ctr"/>
+          </a:p>
+        </p:txBody>
+      </p:sp>
+      <p:sp>
+        <p:nvSpPr>
+          <p:cNvPr id="27" name="TextBox 26"/>
+          <p:cNvSpPr txBox="1"/>
+          <p:nvPr/>
+        </p:nvSpPr>
+        <p:spPr>
+          <a:xfrm>
+            <a:off x="6144768" y="2103120"/>
+            <a:ext cx="5833872" cy="219456"/>
+          </a:xfrm>
+          <a:prstGeom prst="rect">
+            <a:avLst/>
+          </a:prstGeom>
+          <a:noFill/>
+        </p:spPr>
+        <p:txBody>
+          <a:bodyPr wrap="square">
+            <a:spAutoFit/>
+          </a:bodyPr>
+          <a:lstStyle/>
+          <a:p>
+            <a:pPr algn="l"/>
+            <a:r>
+              <a:rPr sz="750" b="1" i="0">
+                <a:solidFill>
+                  <a:srgbClr val="C9A84C"/>
+                </a:solidFill>
+                <a:latin typeface="Calibri"/>
+              </a:rPr>
+              <a:t>── EXAMPLE: ACTIVIST INVESTOR TRIGGER GROUP ──</a:t>
+            </a:r>
+          </a:p>
+        </p:txBody>
+      </p:sp>
+      <p:sp>
+        <p:nvSpPr>
+          <p:cNvPr id="28" name="TextBox 27"/>
+          <p:cNvSpPr txBox="1"/>
+          <p:nvPr/>
+        </p:nvSpPr>
+        <p:spPr>
+          <a:xfrm>
+            <a:off x="6144768" y="2359152"/>
+            <a:ext cx="5833872" cy="219456"/>
+          </a:xfrm>
+          <a:prstGeom prst="rect">
+            <a:avLst/>
+          </a:prstGeom>
+          <a:noFill/>
+        </p:spPr>
+        <p:txBody>
+          <a:bodyPr wrap="square">
+            <a:spAutoFit/>
+          </a:bodyPr>
+          <a:lstStyle/>
+          <a:p>
+            <a:pPr algn="l"/>
+            <a:r>
+              <a:rPr sz="800" b="1" i="0">
+                <a:solidFill>
+                  <a:srgbClr val="AAB4CC"/>
+                </a:solidFill>
+                <a:latin typeface="Calibri"/>
+              </a:rPr>
+              <a:t>Group Threshold:  4 of 5 data points valid  ·  Mandatory: Data Point #1</a:t>
+            </a:r>
+          </a:p>
+        </p:txBody>
+      </p:sp>
+      <p:sp>
+        <p:nvSpPr>
+          <p:cNvPr id="29" name="Rectangle 28"/>
+          <p:cNvSpPr/>
+          <p:nvPr/>
+        </p:nvSpPr>
+        <p:spPr>
+          <a:xfrm>
+            <a:off x="6144768" y="2615184"/>
+            <a:ext cx="5833872" cy="3566160"/>
+          </a:xfrm>
+          <a:prstGeom prst="rect">
+            <a:avLst/>
+          </a:prstGeom>
+          <a:solidFill>
+            <a:srgbClr val="05091E"/>
+          </a:solidFill>
+          <a:ln w="9525">
+            <a:solidFill>
+              <a:srgbClr val="C9A84C"/>
+            </a:solidFill>
+          </a:ln>
+        </p:spPr>
+        <p:style>
+          <a:lnRef idx="1">
+            <a:schemeClr val="accent1"/>
+          </a:lnRef>
+          <a:fillRef idx="3">
+            <a:schemeClr val="accent1"/>
+          </a:fillRef>
+          <a:effectRef idx="2">
+            <a:schemeClr val="accent1"/>
+          </a:effectRef>
+          <a:fontRef idx="minor">
+            <a:schemeClr val="lt1"/>
+          </a:fontRef>
+        </p:style>
+        <p:txBody>
+          <a:bodyPr rtlCol="0" anchor="ctr"/>
+          <a:lstStyle/>
+          <a:p>
+            <a:pPr algn="ctr"/>
+          </a:p>
+        </p:txBody>
+      </p:sp>
+      <p:sp>
+        <p:nvSpPr>
+          <p:cNvPr id="30" name="Rectangle 29"/>
+          <p:cNvSpPr/>
+          <p:nvPr/>
+        </p:nvSpPr>
+        <p:spPr>
+          <a:xfrm>
+            <a:off x="6217920" y="2706624"/>
+            <a:ext cx="5687568" cy="585216"/>
+          </a:xfrm>
+          <a:prstGeom prst="rect">
+            <a:avLst/>
+          </a:prstGeom>
+          <a:solidFill>
+            <a:srgbClr val="1A1206"/>
+          </a:solidFill>
+          <a:ln w="12700">
+            <a:solidFill>
+              <a:srgbClr val="C9A84C"/>
+            </a:solidFill>
+          </a:ln>
+        </p:spPr>
+        <p:style>
+          <a:lnRef idx="1">
+            <a:schemeClr val="accent1"/>
+          </a:lnRef>
+          <a:fillRef idx="3">
+            <a:schemeClr val="accent1"/>
+          </a:fillRef>
+          <a:effectRef idx="2">
+            <a:schemeClr val="accent1"/>
+          </a:effectRef>
+          <a:fontRef idx="minor">
+            <a:schemeClr val="lt1"/>
+          </a:fontRef>
+        </p:style>
+        <p:txBody>
+          <a:bodyPr rtlCol="0" anchor="ctr"/>
+          <a:lstStyle/>
+          <a:p>
+            <a:pPr algn="ctr"/>
+          </a:p>
+        </p:txBody>
+      </p:sp>
+      <p:sp>
+        <p:nvSpPr>
+          <p:cNvPr id="31" name="TextBox 30"/>
+          <p:cNvSpPr txBox="1"/>
+          <p:nvPr/>
+        </p:nvSpPr>
+        <p:spPr>
+          <a:xfrm>
+            <a:off x="6254496" y="2779776"/>
+            <a:ext cx="256032" cy="438912"/>
+          </a:xfrm>
+          <a:prstGeom prst="rect">
+            <a:avLst/>
+          </a:prstGeom>
+          <a:noFill/>
+        </p:spPr>
+        <p:txBody>
+          <a:bodyPr wrap="square">
+            <a:spAutoFit/>
+          </a:bodyPr>
+          <a:lstStyle/>
+          <a:p>
+            <a:pPr algn="l"/>
+            <a:r>
+              <a:rPr sz="900" b="1" i="0">
+                <a:solidFill>
+                  <a:srgbClr val="C9A84C"/>
+                </a:solidFill>
+                <a:latin typeface="Calibri"/>
+              </a:rPr>
+              <a:t>★</a:t>
+            </a:r>
+          </a:p>
+        </p:txBody>
+      </p:sp>
+      <p:sp>
+        <p:nvSpPr>
+          <p:cNvPr id="32" name="TextBox 31"/>
+          <p:cNvSpPr txBox="1"/>
+          <p:nvPr/>
+        </p:nvSpPr>
+        <p:spPr>
+          <a:xfrm>
+            <a:off x="6547104" y="2761488"/>
+            <a:ext cx="3291840" cy="219456"/>
+          </a:xfrm>
+          <a:prstGeom prst="rect">
+            <a:avLst/>
+          </a:prstGeom>
+          <a:noFill/>
+        </p:spPr>
+        <p:txBody>
+          <a:bodyPr wrap="square">
+            <a:spAutoFit/>
+          </a:bodyPr>
+          <a:lstStyle/>
+          <a:p>
+            <a:pPr algn="l"/>
+            <a:r>
+              <a:rPr sz="850" b="1" i="0">
+                <a:solidFill>
+                  <a:srgbClr val="C9A84C"/>
+                </a:solidFill>
+                <a:latin typeface="Calibri"/>
+              </a:rPr>
+              <a:t>SEC 13D Filing Detected</a:t>
+            </a:r>
+          </a:p>
+        </p:txBody>
+      </p:sp>
+      <p:sp>
+        <p:nvSpPr>
+          <p:cNvPr id="33" name="TextBox 32"/>
+          <p:cNvSpPr txBox="1"/>
+          <p:nvPr/>
+        </p:nvSpPr>
+        <p:spPr>
+          <a:xfrm>
+            <a:off x="6547104" y="2999232"/>
+            <a:ext cx="3291840" cy="219456"/>
+          </a:xfrm>
+          <a:prstGeom prst="rect">
+            <a:avLst/>
+          </a:prstGeom>
+          <a:noFill/>
+        </p:spPr>
+        <p:txBody>
+          <a:bodyPr wrap="square">
+            <a:spAutoFit/>
+          </a:bodyPr>
+          <a:lstStyle/>
+          <a:p>
+            <a:pPr algn="l"/>
+            <a:r>
+              <a:rPr sz="750" b="0" i="0">
+                <a:solidFill>
+                  <a:srgbClr val="AAB4CC"/>
+                </a:solidFill>
+                <a:latin typeface="Calibri"/>
+              </a:rPr>
+              <a:t>&gt; 5% ownership disclosure filed with SEC</a:t>
+            </a:r>
+          </a:p>
+        </p:txBody>
+      </p:sp>
+      <p:sp>
+        <p:nvSpPr>
+          <p:cNvPr id="34" name="TextBox 33"/>
+          <p:cNvSpPr txBox="1"/>
+          <p:nvPr/>
+        </p:nvSpPr>
+        <p:spPr>
+          <a:xfrm>
+            <a:off x="9912096" y="2889504"/>
+            <a:ext cx="1810512" cy="219456"/>
+          </a:xfrm>
+          <a:prstGeom prst="rect">
+            <a:avLst/>
+          </a:prstGeom>
+          <a:noFill/>
+        </p:spPr>
+        <p:txBody>
+          <a:bodyPr wrap="square">
+            <a:spAutoFit/>
+          </a:bodyPr>
+          <a:lstStyle/>
+          <a:p>
+            <a:pPr algn="r"/>
+            <a:r>
+              <a:rPr sz="700" b="1" i="0">
+                <a:solidFill>
+                  <a:srgbClr val="C9A84C"/>
+                </a:solidFill>
+                <a:latin typeface="Calibri"/>
+              </a:rPr>
+              <a:t>MANDATORY</a:t>
+            </a:r>
+          </a:p>
+        </p:txBody>
+      </p:sp>
+      <p:sp>
+        <p:nvSpPr>
+          <p:cNvPr id="35" name="Rectangle 34"/>
+          <p:cNvSpPr/>
+          <p:nvPr/>
+        </p:nvSpPr>
+        <p:spPr>
+          <a:xfrm>
+            <a:off x="6217920" y="3364991"/>
+            <a:ext cx="5687568" cy="585216"/>
+          </a:xfrm>
+          <a:prstGeom prst="rect">
+            <a:avLst/>
+          </a:prstGeom>
+          <a:solidFill>
+            <a:srgbClr val="0A160A"/>
+          </a:solidFill>
+          <a:ln w="6350">
+            <a:solidFill>
+              <a:srgbClr val="2B8A6E"/>
+            </a:solidFill>
+          </a:ln>
+        </p:spPr>
+        <p:style>
+          <a:lnRef idx="1">
+            <a:schemeClr val="accent1"/>
+          </a:lnRef>
+          <a:fillRef idx="3">
+            <a:schemeClr val="accent1"/>
+          </a:fillRef>
+          <a:effectRef idx="2">
+            <a:schemeClr val="accent1"/>
+          </a:effectRef>
+          <a:fontRef idx="minor">
+            <a:schemeClr val="lt1"/>
+          </a:fontRef>
+        </p:style>
+        <p:txBody>
+          <a:bodyPr rtlCol="0" anchor="ctr"/>
+          <a:lstStyle/>
+          <a:p>
+            <a:pPr algn="ctr"/>
+          </a:p>
+        </p:txBody>
+      </p:sp>
+      <p:sp>
+        <p:nvSpPr>
+          <p:cNvPr id="36" name="TextBox 35"/>
+          <p:cNvSpPr txBox="1"/>
+          <p:nvPr/>
+        </p:nvSpPr>
+        <p:spPr>
+          <a:xfrm>
+            <a:off x="6254496" y="3438144"/>
+            <a:ext cx="256032" cy="438912"/>
+          </a:xfrm>
+          <a:prstGeom prst="rect">
+            <a:avLst/>
+          </a:prstGeom>
+          <a:noFill/>
+        </p:spPr>
+        <p:txBody>
+          <a:bodyPr wrap="square">
+            <a:spAutoFit/>
+          </a:bodyPr>
+          <a:lstStyle/>
+          <a:p>
+            <a:pPr algn="l"/>
+            <a:r>
+              <a:rPr sz="900" b="1" i="0">
+                <a:solidFill>
+                  <a:srgbClr val="2B8A6E"/>
+                </a:solidFill>
+                <a:latin typeface="Calibri"/>
+              </a:rPr>
+              <a:t>◆</a:t>
+            </a:r>
+          </a:p>
+        </p:txBody>
+      </p:sp>
+      <p:sp>
+        <p:nvSpPr>
+          <p:cNvPr id="37" name="TextBox 36"/>
+          <p:cNvSpPr txBox="1"/>
+          <p:nvPr/>
+        </p:nvSpPr>
+        <p:spPr>
+          <a:xfrm>
+            <a:off x="6547104" y="3419856"/>
+            <a:ext cx="3291840" cy="219456"/>
+          </a:xfrm>
+          <a:prstGeom prst="rect">
+            <a:avLst/>
+          </a:prstGeom>
+          <a:noFill/>
+        </p:spPr>
+        <p:txBody>
+          <a:bodyPr wrap="square">
+            <a:spAutoFit/>
+          </a:bodyPr>
+          <a:lstStyle/>
+          <a:p>
+            <a:pPr algn="l"/>
+            <a:r>
+              <a:rPr sz="850" b="1" i="0">
+                <a:solidFill>
+                  <a:srgbClr val="FFFFFF"/>
+                </a:solidFill>
+                <a:latin typeface="Calibri"/>
+              </a:rPr>
+              <a:t>Institutional Position Change</a:t>
+            </a:r>
+          </a:p>
+        </p:txBody>
+      </p:sp>
+      <p:sp>
+        <p:nvSpPr>
+          <p:cNvPr id="38" name="TextBox 37"/>
+          <p:cNvSpPr txBox="1"/>
+          <p:nvPr/>
+        </p:nvSpPr>
+        <p:spPr>
+          <a:xfrm>
+            <a:off x="6547104" y="3657599"/>
+            <a:ext cx="3291840" cy="219456"/>
+          </a:xfrm>
+          <a:prstGeom prst="rect">
+            <a:avLst/>
+          </a:prstGeom>
+          <a:noFill/>
+        </p:spPr>
+        <p:txBody>
+          <a:bodyPr wrap="square">
+            <a:spAutoFit/>
+          </a:bodyPr>
+          <a:lstStyle/>
+          <a:p>
+            <a:pPr algn="l"/>
+            <a:r>
+              <a:rPr sz="750" b="0" i="0">
+                <a:solidFill>
+                  <a:srgbClr val="AAB4CC"/>
+                </a:solidFill>
+                <a:latin typeface="Calibri"/>
+              </a:rPr>
+              <a:t>&gt; 2% position change in 30-day window</a:t>
+            </a:r>
+          </a:p>
+        </p:txBody>
+      </p:sp>
+      <p:sp>
+        <p:nvSpPr>
+          <p:cNvPr id="39" name="TextBox 38"/>
+          <p:cNvSpPr txBox="1"/>
+          <p:nvPr/>
+        </p:nvSpPr>
+        <p:spPr>
+          <a:xfrm>
+            <a:off x="9912096" y="3547872"/>
+            <a:ext cx="1810512" cy="219456"/>
+          </a:xfrm>
+          <a:prstGeom prst="rect">
+            <a:avLst/>
+          </a:prstGeom>
+          <a:noFill/>
+        </p:spPr>
+        <p:txBody>
+          <a:bodyPr wrap="square">
+            <a:spAutoFit/>
+          </a:bodyPr>
+          <a:lstStyle/>
+          <a:p>
+            <a:pPr algn="r"/>
+            <a:r>
+              <a:rPr sz="700" b="1" i="0">
+                <a:solidFill>
+                  <a:srgbClr val="2B8A6E"/>
+                </a:solidFill>
+                <a:latin typeface="Calibri"/>
+              </a:rPr>
+              <a:t>THRESHOLD MET</a:t>
+            </a:r>
+          </a:p>
+        </p:txBody>
+      </p:sp>
+      <p:sp>
+        <p:nvSpPr>
+          <p:cNvPr id="40" name="Rectangle 39"/>
+          <p:cNvSpPr/>
+          <p:nvPr/>
+        </p:nvSpPr>
+        <p:spPr>
+          <a:xfrm>
+            <a:off x="6217920" y="4023360"/>
+            <a:ext cx="5687568" cy="585216"/>
+          </a:xfrm>
+          <a:prstGeom prst="rect">
+            <a:avLst/>
+          </a:prstGeom>
+          <a:solidFill>
+            <a:srgbClr val="0A160A"/>
+          </a:solidFill>
+          <a:ln w="6350">
+            <a:solidFill>
+              <a:srgbClr val="2B8A6E"/>
+            </a:solidFill>
+          </a:ln>
+        </p:spPr>
+        <p:style>
+          <a:lnRef idx="1">
+            <a:schemeClr val="accent1"/>
+          </a:lnRef>
+          <a:fillRef idx="3">
+            <a:schemeClr val="accent1"/>
+          </a:fillRef>
+          <a:effectRef idx="2">
+            <a:schemeClr val="accent1"/>
+          </a:effectRef>
+          <a:fontRef idx="minor">
+            <a:schemeClr val="lt1"/>
+          </a:fontRef>
+        </p:style>
+        <p:txBody>
+          <a:bodyPr rtlCol="0" anchor="ctr"/>
+          <a:lstStyle/>
+          <a:p>
+            <a:pPr algn="ctr"/>
+          </a:p>
+        </p:txBody>
+      </p:sp>
+      <p:sp>
+        <p:nvSpPr>
+          <p:cNvPr id="41" name="TextBox 40"/>
+          <p:cNvSpPr txBox="1"/>
+          <p:nvPr/>
+        </p:nvSpPr>
+        <p:spPr>
+          <a:xfrm>
+            <a:off x="6254496" y="4096512"/>
+            <a:ext cx="256032" cy="438912"/>
+          </a:xfrm>
+          <a:prstGeom prst="rect">
+            <a:avLst/>
+          </a:prstGeom>
+          <a:noFill/>
+        </p:spPr>
+        <p:txBody>
+          <a:bodyPr wrap="square">
+            <a:spAutoFit/>
+          </a:bodyPr>
+          <a:lstStyle/>
+          <a:p>
+            <a:pPr algn="l"/>
+            <a:r>
+              <a:rPr sz="900" b="1" i="0">
+                <a:solidFill>
+                  <a:srgbClr val="2B8A6E"/>
+                </a:solidFill>
+                <a:latin typeface="Calibri"/>
+              </a:rPr>
+              <a:t>◆</a:t>
+            </a:r>
+          </a:p>
+        </p:txBody>
+      </p:sp>
+      <p:sp>
+        <p:nvSpPr>
+          <p:cNvPr id="42" name="TextBox 41"/>
+          <p:cNvSpPr txBox="1"/>
+          <p:nvPr/>
+        </p:nvSpPr>
+        <p:spPr>
+          <a:xfrm>
+            <a:off x="6547104" y="4078224"/>
+            <a:ext cx="3291840" cy="219456"/>
+          </a:xfrm>
+          <a:prstGeom prst="rect">
+            <a:avLst/>
+          </a:prstGeom>
+          <a:noFill/>
+        </p:spPr>
+        <p:txBody>
+          <a:bodyPr wrap="square">
+            <a:spAutoFit/>
+          </a:bodyPr>
+          <a:lstStyle/>
+          <a:p>
+            <a:pPr algn="l"/>
+            <a:r>
+              <a:rPr sz="850" b="1" i="0">
+                <a:solidFill>
+                  <a:srgbClr val="FFFFFF"/>
+                </a:solidFill>
+                <a:latin typeface="Calibri"/>
+              </a:rPr>
+              <a:t>Board Communication Volume</a:t>
+            </a:r>
+          </a:p>
+        </p:txBody>
+      </p:sp>
+      <p:sp>
+        <p:nvSpPr>
+          <p:cNvPr id="43" name="TextBox 42"/>
+          <p:cNvSpPr txBox="1"/>
+          <p:nvPr/>
+        </p:nvSpPr>
+        <p:spPr>
+          <a:xfrm>
+            <a:off x="6547104" y="4315968"/>
+            <a:ext cx="3291840" cy="219456"/>
+          </a:xfrm>
+          <a:prstGeom prst="rect">
+            <a:avLst/>
+          </a:prstGeom>
+          <a:noFill/>
+        </p:spPr>
+        <p:txBody>
+          <a:bodyPr wrap="square">
+            <a:spAutoFit/>
+          </a:bodyPr>
+          <a:lstStyle/>
+          <a:p>
+            <a:pPr algn="l"/>
+            <a:r>
+              <a:rPr sz="750" b="0" i="0">
+                <a:solidFill>
+                  <a:srgbClr val="AAB4CC"/>
+                </a:solidFill>
+                <a:latin typeface="Calibri"/>
+              </a:rPr>
+              <a:t>&gt; 40% above 90-day baseline activity</a:t>
+            </a:r>
+          </a:p>
+        </p:txBody>
+      </p:sp>
+      <p:sp>
+        <p:nvSpPr>
+          <p:cNvPr id="44" name="TextBox 43"/>
+          <p:cNvSpPr txBox="1"/>
+          <p:nvPr/>
+        </p:nvSpPr>
+        <p:spPr>
+          <a:xfrm>
+            <a:off x="9912096" y="4206240"/>
+            <a:ext cx="1810512" cy="219456"/>
+          </a:xfrm>
+          <a:prstGeom prst="rect">
+            <a:avLst/>
+          </a:prstGeom>
+          <a:noFill/>
+        </p:spPr>
+        <p:txBody>
+          <a:bodyPr wrap="square">
+            <a:spAutoFit/>
+          </a:bodyPr>
+          <a:lstStyle/>
+          <a:p>
+            <a:pPr algn="r"/>
+            <a:r>
+              <a:rPr sz="700" b="1" i="0">
+                <a:solidFill>
+                  <a:srgbClr val="2B8A6E"/>
+                </a:solidFill>
+                <a:latin typeface="Calibri"/>
+              </a:rPr>
+              <a:t>THRESHOLD MET</a:t>
+            </a:r>
+          </a:p>
+        </p:txBody>
+      </p:sp>
+      <p:sp>
+        <p:nvSpPr>
+          <p:cNvPr id="45" name="Rectangle 44"/>
+          <p:cNvSpPr/>
+          <p:nvPr/>
+        </p:nvSpPr>
+        <p:spPr>
+          <a:xfrm>
+            <a:off x="6217920" y="4681728"/>
+            <a:ext cx="5687568" cy="585216"/>
+          </a:xfrm>
+          <a:prstGeom prst="rect">
+            <a:avLst/>
+          </a:prstGeom>
+          <a:solidFill>
+            <a:srgbClr val="070B24"/>
+          </a:solidFill>
+          <a:ln w="6350">
+            <a:solidFill>
+              <a:srgbClr val="1A2450"/>
+            </a:solidFill>
+          </a:ln>
+        </p:spPr>
+        <p:style>
+          <a:lnRef idx="1">
+            <a:schemeClr val="accent1"/>
+          </a:lnRef>
+          <a:fillRef idx="3">
+            <a:schemeClr val="accent1"/>
+          </a:fillRef>
+          <a:effectRef idx="2">
+            <a:schemeClr val="accent1"/>
+          </a:effectRef>
+          <a:fontRef idx="minor">
+            <a:schemeClr val="lt1"/>
+          </a:fontRef>
+        </p:style>
+        <p:txBody>
+          <a:bodyPr rtlCol="0" anchor="ctr"/>
+          <a:lstStyle/>
+          <a:p>
+            <a:pPr algn="ctr"/>
+          </a:p>
+        </p:txBody>
+      </p:sp>
+      <p:sp>
+        <p:nvSpPr>
+          <p:cNvPr id="46" name="TextBox 45"/>
+          <p:cNvSpPr txBox="1"/>
+          <p:nvPr/>
+        </p:nvSpPr>
+        <p:spPr>
+          <a:xfrm>
+            <a:off x="6254496" y="4754880"/>
+            <a:ext cx="256032" cy="438912"/>
+          </a:xfrm>
+          <a:prstGeom prst="rect">
+            <a:avLst/>
+          </a:prstGeom>
+          <a:noFill/>
+        </p:spPr>
+        <p:txBody>
+          <a:bodyPr wrap="square">
+            <a:spAutoFit/>
+          </a:bodyPr>
+          <a:lstStyle/>
+          <a:p>
+            <a:pPr algn="l"/>
+            <a:r>
+              <a:rPr sz="900" b="1" i="0">
+                <a:solidFill>
+                  <a:srgbClr val="AAB4CC"/>
+                </a:solidFill>
+                <a:latin typeface="Calibri"/>
+              </a:rPr>
+              <a:t>◆</a:t>
+            </a:r>
+          </a:p>
+        </p:txBody>
+      </p:sp>
+      <p:sp>
+        <p:nvSpPr>
+          <p:cNvPr id="47" name="TextBox 46"/>
+          <p:cNvSpPr txBox="1"/>
+          <p:nvPr/>
+        </p:nvSpPr>
+        <p:spPr>
+          <a:xfrm>
+            <a:off x="6547104" y="4736592"/>
+            <a:ext cx="3291840" cy="219456"/>
+          </a:xfrm>
+          <a:prstGeom prst="rect">
+            <a:avLst/>
+          </a:prstGeom>
+          <a:noFill/>
+        </p:spPr>
+        <p:txBody>
+          <a:bodyPr wrap="square">
+            <a:spAutoFit/>
+          </a:bodyPr>
+          <a:lstStyle/>
+          <a:p>
+            <a:pPr algn="l"/>
+            <a:r>
+              <a:rPr sz="850" b="1" i="0">
+                <a:solidFill>
+                  <a:srgbClr val="FFFFFF"/>
+                </a:solidFill>
+                <a:latin typeface="Calibri"/>
+              </a:rPr>
+              <a:t>Proxy Advisor Engagement</a:t>
+            </a:r>
+          </a:p>
+        </p:txBody>
+      </p:sp>
+      <p:sp>
+        <p:nvSpPr>
+          <p:cNvPr id="48" name="TextBox 47"/>
+          <p:cNvSpPr txBox="1"/>
+          <p:nvPr/>
+        </p:nvSpPr>
+        <p:spPr>
+          <a:xfrm>
+            <a:off x="6547104" y="4974336"/>
+            <a:ext cx="3291840" cy="219456"/>
+          </a:xfrm>
+          <a:prstGeom prst="rect">
+            <a:avLst/>
+          </a:prstGeom>
+          <a:noFill/>
+        </p:spPr>
+        <p:txBody>
+          <a:bodyPr wrap="square">
+            <a:spAutoFit/>
+          </a:bodyPr>
+          <a:lstStyle/>
+          <a:p>
+            <a:pPr algn="l"/>
+            <a:r>
+              <a:rPr sz="750" b="0" i="0">
+                <a:solidFill>
+                  <a:srgbClr val="AAB4CC"/>
+                </a:solidFill>
+                <a:latin typeface="Calibri"/>
+              </a:rPr>
+              <a:t>2+ advisors engaged — monitoring</a:t>
+            </a:r>
+          </a:p>
+        </p:txBody>
+      </p:sp>
+      <p:sp>
+        <p:nvSpPr>
+          <p:cNvPr id="49" name="TextBox 48"/>
+          <p:cNvSpPr txBox="1"/>
+          <p:nvPr/>
+        </p:nvSpPr>
+        <p:spPr>
+          <a:xfrm>
+            <a:off x="9912096" y="4864608"/>
+            <a:ext cx="1810512" cy="219456"/>
+          </a:xfrm>
+          <a:prstGeom prst="rect">
+            <a:avLst/>
+          </a:prstGeom>
+          <a:noFill/>
+        </p:spPr>
+        <p:txBody>
+          <a:bodyPr wrap="square">
+            <a:spAutoFit/>
+          </a:bodyPr>
+          <a:lstStyle/>
+          <a:p>
+            <a:pPr algn="r"/>
+            <a:r>
+              <a:rPr sz="700" b="1" i="0">
+                <a:solidFill>
+                  <a:srgbClr val="AAB4CC"/>
+                </a:solidFill>
+                <a:latin typeface="Calibri"/>
+              </a:rPr>
+              <a:t>PENDING</a:t>
+            </a:r>
+          </a:p>
+        </p:txBody>
+      </p:sp>
+      <p:sp>
+        <p:nvSpPr>
+          <p:cNvPr id="50" name="Rectangle 49"/>
+          <p:cNvSpPr/>
+          <p:nvPr/>
+        </p:nvSpPr>
+        <p:spPr>
+          <a:xfrm>
+            <a:off x="6217920" y="5340096"/>
+            <a:ext cx="5687568" cy="585216"/>
+          </a:xfrm>
+          <a:prstGeom prst="rect">
+            <a:avLst/>
+          </a:prstGeom>
+          <a:solidFill>
+            <a:srgbClr val="0A160A"/>
+          </a:solidFill>
+          <a:ln w="6350">
+            <a:solidFill>
+              <a:srgbClr val="2B8A6E"/>
+            </a:solidFill>
+          </a:ln>
+        </p:spPr>
+        <p:style>
+          <a:lnRef idx="1">
+            <a:schemeClr val="accent1"/>
+          </a:lnRef>
+          <a:fillRef idx="3">
+            <a:schemeClr val="accent1"/>
+          </a:fillRef>
+          <a:effectRef idx="2">
+            <a:schemeClr val="accent1"/>
+          </a:effectRef>
+          <a:fontRef idx="minor">
+            <a:schemeClr val="lt1"/>
+          </a:fontRef>
+        </p:style>
+        <p:txBody>
+          <a:bodyPr rtlCol="0" anchor="ctr"/>
+          <a:lstStyle/>
+          <a:p>
+            <a:pPr algn="ctr"/>
+          </a:p>
+        </p:txBody>
+      </p:sp>
+      <p:sp>
+        <p:nvSpPr>
+          <p:cNvPr id="51" name="TextBox 50"/>
+          <p:cNvSpPr txBox="1"/>
+          <p:nvPr/>
+        </p:nvSpPr>
+        <p:spPr>
+          <a:xfrm>
+            <a:off x="6254496" y="5413248"/>
+            <a:ext cx="256032" cy="438912"/>
+          </a:xfrm>
+          <a:prstGeom prst="rect">
+            <a:avLst/>
+          </a:prstGeom>
+          <a:noFill/>
+        </p:spPr>
+        <p:txBody>
+          <a:bodyPr wrap="square">
+            <a:spAutoFit/>
+          </a:bodyPr>
+          <a:lstStyle/>
+          <a:p>
+            <a:pPr algn="l"/>
+            <a:r>
+              <a:rPr sz="900" b="1" i="0">
+                <a:solidFill>
+                  <a:srgbClr val="2B8A6E"/>
+                </a:solidFill>
+                <a:latin typeface="Calibri"/>
+              </a:rPr>
+              <a:t>◆</a:t>
+            </a:r>
+          </a:p>
+        </p:txBody>
+      </p:sp>
+      <p:sp>
+        <p:nvSpPr>
+          <p:cNvPr id="52" name="TextBox 51"/>
+          <p:cNvSpPr txBox="1"/>
+          <p:nvPr/>
+        </p:nvSpPr>
+        <p:spPr>
+          <a:xfrm>
+            <a:off x="6547104" y="5394959"/>
+            <a:ext cx="3291840" cy="219456"/>
+          </a:xfrm>
+          <a:prstGeom prst="rect">
+            <a:avLst/>
+          </a:prstGeom>
+          <a:noFill/>
+        </p:spPr>
+        <p:txBody>
+          <a:bodyPr wrap="square">
+            <a:spAutoFit/>
+          </a:bodyPr>
+          <a:lstStyle/>
+          <a:p>
+            <a:pPr algn="l"/>
+            <a:r>
+              <a:rPr sz="850" b="1" i="0">
+                <a:solidFill>
+                  <a:srgbClr val="FFFFFF"/>
+                </a:solidFill>
+                <a:latin typeface="Calibri"/>
+              </a:rPr>
+              <a:t>Media Sentiment Score</a:t>
+            </a:r>
+          </a:p>
+        </p:txBody>
+      </p:sp>
+      <p:sp>
+        <p:nvSpPr>
+          <p:cNvPr id="53" name="TextBox 52"/>
+          <p:cNvSpPr txBox="1"/>
+          <p:nvPr/>
+        </p:nvSpPr>
+        <p:spPr>
+          <a:xfrm>
+            <a:off x="6547104" y="5632704"/>
+            <a:ext cx="3291840" cy="219456"/>
+          </a:xfrm>
+          <a:prstGeom prst="rect">
+            <a:avLst/>
+          </a:prstGeom>
+          <a:noFill/>
+        </p:spPr>
+        <p:txBody>
+          <a:bodyPr wrap="square">
+            <a:spAutoFit/>
+          </a:bodyPr>
+          <a:lstStyle/>
+          <a:p>
+            <a:pPr algn="l"/>
+            <a:r>
+              <a:rPr sz="750" b="0" i="0">
+                <a:solidFill>
+                  <a:srgbClr val="AAB4CC"/>
+                </a:solidFill>
+                <a:latin typeface="Calibri"/>
+              </a:rPr>
+              <a:t>Sentiment index &lt; 35 (negative zone)</a:t>
+            </a:r>
+          </a:p>
+        </p:txBody>
+      </p:sp>
+      <p:sp>
+        <p:nvSpPr>
+          <p:cNvPr id="54" name="TextBox 53"/>
+          <p:cNvSpPr txBox="1"/>
+          <p:nvPr/>
+        </p:nvSpPr>
+        <p:spPr>
+          <a:xfrm>
+            <a:off x="9912096" y="5522976"/>
+            <a:ext cx="1810512" cy="219456"/>
+          </a:xfrm>
+          <a:prstGeom prst="rect">
+            <a:avLst/>
+          </a:prstGeom>
+          <a:noFill/>
+        </p:spPr>
+        <p:txBody>
+          <a:bodyPr wrap="square">
+            <a:spAutoFit/>
+          </a:bodyPr>
+          <a:lstStyle/>
+          <a:p>
+            <a:pPr algn="r"/>
+            <a:r>
+              <a:rPr sz="700" b="1" i="0">
+                <a:solidFill>
+                  <a:srgbClr val="2B8A6E"/>
+                </a:solidFill>
+                <a:latin typeface="Calibri"/>
+              </a:rPr>
+              <a:t>THRESHOLD MET</a:t>
+            </a:r>
+          </a:p>
+        </p:txBody>
+      </p:sp>
+      <p:sp>
+        <p:nvSpPr>
+          <p:cNvPr id="55" name="Rectangle 54"/>
+          <p:cNvSpPr/>
+          <p:nvPr/>
+        </p:nvSpPr>
+        <p:spPr>
+          <a:xfrm>
+            <a:off x="6144768" y="6217920"/>
+            <a:ext cx="5833872" cy="384048"/>
+          </a:xfrm>
+          <a:prstGeom prst="rect">
+            <a:avLst/>
+          </a:prstGeom>
+          <a:solidFill>
+            <a:srgbClr val="0A200A"/>
+          </a:solidFill>
+          <a:ln w="12700">
+            <a:solidFill>
+              <a:srgbClr val="2B8A6E"/>
+            </a:solidFill>
+          </a:ln>
+        </p:spPr>
+        <p:style>
+          <a:lnRef idx="1">
+            <a:schemeClr val="accent1"/>
+          </a:lnRef>
+          <a:fillRef idx="3">
+            <a:schemeClr val="accent1"/>
+          </a:fillRef>
+          <a:effectRef idx="2">
+            <a:schemeClr val="accent1"/>
+          </a:effectRef>
+          <a:fontRef idx="minor">
+            <a:schemeClr val="lt1"/>
+          </a:fontRef>
+        </p:style>
+        <p:txBody>
+          <a:bodyPr rtlCol="0" anchor="ctr"/>
+          <a:lstStyle/>
+          <a:p>
+            <a:pPr algn="ctr"/>
+          </a:p>
+        </p:txBody>
+      </p:sp>
+      <p:sp>
+        <p:nvSpPr>
+          <p:cNvPr id="56" name="TextBox 55"/>
+          <p:cNvSpPr txBox="1"/>
+          <p:nvPr/>
+        </p:nvSpPr>
+        <p:spPr>
+          <a:xfrm>
+            <a:off x="6272784" y="6272784"/>
+            <a:ext cx="5614416" cy="256032"/>
+          </a:xfrm>
+          <a:prstGeom prst="rect">
+            <a:avLst/>
+          </a:prstGeom>
+          <a:noFill/>
+        </p:spPr>
+        <p:txBody>
+          <a:bodyPr wrap="square">
+            <a:spAutoFit/>
+          </a:bodyPr>
+          <a:lstStyle/>
+          <a:p>
+            <a:pPr algn="ctr"/>
+            <a:r>
+              <a:rPr sz="800" b="1" i="0">
+                <a:solidFill>
+                  <a:srgbClr val="2B8A6E"/>
+                </a:solidFill>
+                <a:latin typeface="Calibri"/>
+              </a:rPr>
+              <a:t>4 / 5 VALID  ·  MANDATORY MET  →  PROTOCOL #58 ACTIVATED  —  WAR ROOM OPEN</a:t>
+            </a:r>
+          </a:p>
+        </p:txBody>
+      </p:sp>
+      <p:sp>
+        <p:nvSpPr>
+          <p:cNvPr id="57" name="Rectangle 56"/>
+          <p:cNvSpPr/>
+          <p:nvPr/>
+        </p:nvSpPr>
+        <p:spPr>
+          <a:xfrm>
+            <a:off x="438912" y="6126480"/>
+            <a:ext cx="5303520" cy="256032"/>
+          </a:xfrm>
+          <a:prstGeom prst="rect">
+            <a:avLst/>
+          </a:prstGeom>
+          <a:solidFill>
+            <a:srgbClr val="040814"/>
+          </a:solidFill>
+          <a:ln>
+            <a:noFill/>
+          </a:ln>
+        </p:spPr>
+        <p:style>
+          <a:lnRef idx="1">
+            <a:schemeClr val="accent1"/>
+          </a:lnRef>
+          <a:fillRef idx="3">
+            <a:schemeClr val="accent1"/>
+          </a:fillRef>
+          <a:effectRef idx="2">
+            <a:schemeClr val="accent1"/>
+          </a:effectRef>
+          <a:fontRef idx="minor">
+            <a:schemeClr val="lt1"/>
+          </a:fontRef>
+        </p:style>
+        <p:txBody>
+          <a:bodyPr rtlCol="0" anchor="ctr"/>
+          <a:lstStyle/>
+          <a:p>
+            <a:pPr algn="ctr"/>
+          </a:p>
+        </p:txBody>
+      </p:sp>
+      <p:sp>
+        <p:nvSpPr>
+          <p:cNvPr id="58" name="TextBox 57"/>
+          <p:cNvSpPr txBox="1"/>
+          <p:nvPr/>
+        </p:nvSpPr>
+        <p:spPr>
+          <a:xfrm>
+            <a:off x="566928" y="6144768"/>
+            <a:ext cx="5138928" cy="201168"/>
+          </a:xfrm>
+          <a:prstGeom prst="rect">
+            <a:avLst/>
+          </a:prstGeom>
+          <a:noFill/>
+        </p:spPr>
+        <p:txBody>
+          <a:bodyPr wrap="square">
+            <a:spAutoFit/>
+          </a:bodyPr>
+          <a:lstStyle/>
+          <a:p>
+            <a:pPr algn="l"/>
+            <a:r>
+              <a:rPr sz="800" b="0" i="1">
+                <a:solidFill>
+                  <a:srgbClr val="C9A84C"/>
+                </a:solidFill>
+                <a:latin typeface="Calibri"/>
+              </a:rPr>
+              <a:t>Result: Protocol #58 — Activist Investor Defense deploys · 12-minute execution begins</a:t>
+            </a:r>
           </a:p>
         </p:txBody>
       </p:sp>
@@ -15648,7 +17793,7 @@
                 </a:solidFill>
                 <a:latin typeface="Calibri"/>
               </a:rPr>
-              <a:t>01  /  17</a:t>
+              <a:t>01  /  18</a:t>
             </a:r>
           </a:p>
         </p:txBody>
@@ -16578,7 +18723,7 @@
                 </a:solidFill>
                 <a:latin typeface="Calibri"/>
               </a:rPr>
-              <a:t>02  /  17</a:t>
+              <a:t>02  /  18</a:t>
             </a:r>
           </a:p>
         </p:txBody>
@@ -18456,7 +20601,7 @@
                 </a:solidFill>
                 <a:latin typeface="Calibri"/>
               </a:rPr>
-              <a:t>03  /  17</a:t>
+              <a:t>03  /  18</a:t>
             </a:r>
           </a:p>
         </p:txBody>
@@ -19980,7 +22125,7 @@
                 </a:solidFill>
                 <a:latin typeface="Calibri"/>
               </a:rPr>
-              <a:t>04  /  17</a:t>
+              <a:t>04  /  18</a:t>
             </a:r>
           </a:p>
         </p:txBody>
@@ -21255,7 +23400,7 @@
                 </a:solidFill>
                 <a:latin typeface="Calibri"/>
               </a:rPr>
-              <a:t>05  /  17</a:t>
+              <a:t>05  /  18</a:t>
             </a:r>
           </a:p>
         </p:txBody>
@@ -22695,7 +24840,7 @@
                 </a:solidFill>
                 <a:latin typeface="Calibri"/>
               </a:rPr>
-              <a:t>06  /  17</a:t>
+              <a:t>07  /  18</a:t>
             </a:r>
           </a:p>
         </p:txBody>
@@ -23946,7 +26091,7 @@
                 </a:solidFill>
                 <a:latin typeface="Calibri"/>
               </a:rPr>
-              <a:t>07  /  17</a:t>
+              <a:t>08  /  18</a:t>
             </a:r>
           </a:p>
         </p:txBody>
@@ -25962,7 +28107,7 @@
                 </a:solidFill>
                 <a:latin typeface="Calibri"/>
               </a:rPr>
-              <a:t>08  /  17</a:t>
+              <a:t>09  /  18</a:t>
             </a:r>
           </a:p>
         </p:txBody>

</xml_diff>